<commit_message>
chore: add .err files and pdfs/ to .gitignore
</commit_message>
<xml_diff>
--- a/docs/presentation/2026-global-azure-columbus.pptx
+++ b/docs/presentation/2026-global-azure-columbus.pptx
@@ -296,7 +296,7 @@
           <a:lstStyle/>
           <a:p>
             <a:r>
-              <a:rPr lang="en-US" dirty="0"/>
+              <a:rPr lang="en-US" sz="1400" dirty="0"/>
               <a:t>Welcome to Global Azure Columbus. I'm Shawn Wallace, Principal Architect at Centric Consulting. This talk is about moving your team from solo Copilot wins to agentic-first workflows. The repo with everything I'm about to show — instructions, skills, agents, demo app, the whole .github/ folder — is at github.com/shawnewallace/2026-global-azure-columbus. Grab it, follow along, fork it after. Core thesis, and we'll come back to this: the agent isn't the point. The system your team builds around it is.</a:t>
             </a:r>
           </a:p>
@@ -558,7 +558,43 @@
           <a:p>
             <a:r>
               <a:rPr lang="en-US" sz="4000" dirty="0"/>
-              <a:t>Six demo steps. Narrate each. 1) SET THE SCENE — open VS Code, walk the .github/ folder. Point to copilot-instructions.md, instructions/, agents/, plugins/azure-skills/. Open azure-prepare/SKILL.md and show it's plain text. 'Version-controlled. PR-reviewed. Not a black box.' 2) azure-prepare — prompt: 'Prepare this app for Azure. The app uses Azure OpenAI for AI-powered task prioritization — make sure the OpenAI resource and model deployment are included.' Watch: Dockerfile, azure.yaml, Bicep with Postgres + Key Vault + Azure OpenAI + managed identity. KEY MOMENT: the skill finds AzureOpenAILlmService.cs in the code and provisions OpenAI without being told. 'The skill read the codebase — you didn't have to tell it.' 3) azure-validate — prompt: 'Validate my Azure deployment files before I run azd up.' Pre-flight: quotas, RBAC, naming, region. Green = safe to proceed. 4) azure-deploy — prompt: 'Deploy this project to Azure.' azd up runs. Narrate: 'No secrets. DefaultAzureCredential. The skill encoded that practice.' 5) Operate — use @azure to query live resources: 'list my resource groups', 'show app insights for the function app'. 6) azure-diagnostics — prompt: 'Troubleshoot why my app is failing health probes.' Show CorrelationId, PromptTokens, CompletionTokens, LatencyMs in App Insights logs. Close with: 'The coding agent wrote this. The skill deployed it. The operations skill read it back.'</a:t>
+              <a:t>Six demo steps. Narrate each.</a:t>
+            </a:r>
+          </a:p>
+          <a:p>
+            <a:r>
+              <a:rPr lang="en-US" sz="4000" dirty="0"/>
+              <a:t>1) SET THE SCENE — open VS Code, walk the .github/ folder. Point to copilot-instructions.md, instructions/, agents/, plugins/azure-skills/. Open azure-prepare/SKILL.md and show it's plain text. 'Version-controlled. PR-reviewed. Not a black box.' </a:t>
+            </a:r>
+          </a:p>
+          <a:p>
+            <a:r>
+              <a:rPr lang="en-US" sz="4000" dirty="0"/>
+              <a:t>2) azure-prepare — prompt: 'Prepare this app for Azure. The app uses Azure OpenAI for AI-powered task prioritization — make sure the OpenAI resource and model deployment are included.' Watch: Dockerfile, azure.yaml, Bicep with Postgres + Key Vault + Azure OpenAI + managed identity. KEY MOMENT: the skill finds AzureOpenAILlmService.cs in the code and provisions OpenAI without being told. 'The skill read the codebase — you didn't have to tell it.’ </a:t>
+            </a:r>
+          </a:p>
+          <a:p>
+            <a:r>
+              <a:rPr lang="en-US" sz="4000" dirty="0"/>
+              <a:t>3) azure-validate — prompt: 'Validate my Azure deployment files before I run azd up.' Pre-flight: quotas, RBAC, naming, region. Green = safe to proceed. </a:t>
+            </a:r>
+          </a:p>
+          <a:p>
+            <a:r>
+              <a:rPr lang="en-US" sz="4000" dirty="0"/>
+              <a:t>4) azure-deploy — prompt: 'Deploy this project to Azure.' azd up runs. Narrate: 'No secrets. DefaultAzureCredential. The skill encoded that practice.’ </a:t>
+            </a:r>
+          </a:p>
+          <a:p>
+            <a:r>
+              <a:rPr lang="en-US" sz="4000" dirty="0"/>
+              <a:t>5) Operate — use @azure to query live resources: 'list my resource groups', 'show app insights for the function app’. </a:t>
+            </a:r>
+          </a:p>
+          <a:p>
+            <a:r>
+              <a:rPr lang="en-US" sz="4000" dirty="0"/>
+              <a:t>6) azure-diagnostics — prompt: 'Troubleshoot why my app is failing health probes.' Show CorrelationId, PromptTokens, CompletionTokens, LatencyMs in App Insights logs. Close with: 'The coding agent wrote this. The skill deployed it. The operations skill read it back.'</a:t>
             </a:r>
           </a:p>
         </p:txBody>
@@ -2291,6 +2327,18 @@
   <p:clrMapOvr>
     <a:masterClrMapping/>
   </p:clrMapOvr>
+  <mc:AlternateContent xmlns:mc="http://schemas.openxmlformats.org/markup-compatibility/2006" xmlns:p14="http://schemas.microsoft.com/office/powerpoint/2010/main">
+    <mc:Choice Requires="p14">
+      <p:transition spd="med" p14:dur="700">
+        <p:fade/>
+      </p:transition>
+    </mc:Choice>
+    <mc:Fallback xmlns="">
+      <p:transition spd="med">
+        <p:fade/>
+      </p:transition>
+    </mc:Fallback>
+  </mc:AlternateContent>
 </p:sld>
 </file>
 
@@ -3111,6 +3159,18 @@
   <p:clrMapOvr>
     <a:masterClrMapping/>
   </p:clrMapOvr>
+  <mc:AlternateContent xmlns:mc="http://schemas.openxmlformats.org/markup-compatibility/2006" xmlns:p14="http://schemas.microsoft.com/office/powerpoint/2010/main">
+    <mc:Choice Requires="p14">
+      <p:transition spd="med" p14:dur="700">
+        <p:fade/>
+      </p:transition>
+    </mc:Choice>
+    <mc:Fallback xmlns="">
+      <p:transition spd="med">
+        <p:fade/>
+      </p:transition>
+    </mc:Fallback>
+  </mc:AlternateContent>
 </p:sld>
 </file>
 
@@ -3459,6 +3519,18 @@
   <p:clrMapOvr>
     <a:masterClrMapping/>
   </p:clrMapOvr>
+  <mc:AlternateContent xmlns:mc="http://schemas.openxmlformats.org/markup-compatibility/2006" xmlns:p14="http://schemas.microsoft.com/office/powerpoint/2010/main">
+    <mc:Choice Requires="p14">
+      <p:transition spd="med" p14:dur="700">
+        <p:fade/>
+      </p:transition>
+    </mc:Choice>
+    <mc:Fallback xmlns="">
+      <p:transition spd="med">
+        <p:fade/>
+      </p:transition>
+    </mc:Fallback>
+  </mc:AlternateContent>
 </p:sld>
 </file>
 
@@ -5023,6 +5095,18 @@
   <p:clrMapOvr>
     <a:masterClrMapping/>
   </p:clrMapOvr>
+  <mc:AlternateContent xmlns:mc="http://schemas.openxmlformats.org/markup-compatibility/2006" xmlns:p14="http://schemas.microsoft.com/office/powerpoint/2010/main">
+    <mc:Choice Requires="p14">
+      <p:transition spd="med" p14:dur="700">
+        <p:fade/>
+      </p:transition>
+    </mc:Choice>
+    <mc:Fallback xmlns="">
+      <p:transition spd="med">
+        <p:fade/>
+      </p:transition>
+    </mc:Fallback>
+  </mc:AlternateContent>
 </p:sld>
 </file>
 
@@ -6135,6 +6219,18 @@
   <p:clrMapOvr>
     <a:masterClrMapping/>
   </p:clrMapOvr>
+  <mc:AlternateContent xmlns:mc="http://schemas.openxmlformats.org/markup-compatibility/2006" xmlns:p14="http://schemas.microsoft.com/office/powerpoint/2010/main">
+    <mc:Choice Requires="p14">
+      <p:transition spd="med" p14:dur="700">
+        <p:fade/>
+      </p:transition>
+    </mc:Choice>
+    <mc:Fallback xmlns="">
+      <p:transition spd="med">
+        <p:fade/>
+      </p:transition>
+    </mc:Fallback>
+  </mc:AlternateContent>
 </p:sld>
 </file>
 
@@ -7101,6 +7197,18 @@
   <p:clrMapOvr>
     <a:masterClrMapping/>
   </p:clrMapOvr>
+  <mc:AlternateContent xmlns:mc="http://schemas.openxmlformats.org/markup-compatibility/2006" xmlns:p14="http://schemas.microsoft.com/office/powerpoint/2010/main">
+    <mc:Choice Requires="p14">
+      <p:transition spd="med" p14:dur="700">
+        <p:fade/>
+      </p:transition>
+    </mc:Choice>
+    <mc:Fallback xmlns="">
+      <p:transition spd="med">
+        <p:fade/>
+      </p:transition>
+    </mc:Fallback>
+  </mc:AlternateContent>
 </p:sld>
 </file>
 
@@ -7717,6 +7825,18 @@
   <p:clrMapOvr>
     <a:masterClrMapping/>
   </p:clrMapOvr>
+  <mc:AlternateContent xmlns:mc="http://schemas.openxmlformats.org/markup-compatibility/2006" xmlns:p14="http://schemas.microsoft.com/office/powerpoint/2010/main">
+    <mc:Choice Requires="p14">
+      <p:transition spd="med" p14:dur="700">
+        <p:fade/>
+      </p:transition>
+    </mc:Choice>
+    <mc:Fallback xmlns="">
+      <p:transition spd="med">
+        <p:fade/>
+      </p:transition>
+    </mc:Fallback>
+  </mc:AlternateContent>
 </p:sld>
 </file>
 
@@ -7990,7 +8110,7 @@
                 <a:ea typeface="Calibri" pitchFamily="34" charset="-122"/>
                 <a:cs typeface="Calibri" pitchFamily="34" charset="-120"/>
               </a:rPr>
-              <a:t>Who uses Copilot for autocomplete?</a:t>
+              <a:t>Who uses Copilot right now?</a:t>
             </a:r>
             <a:endParaRPr lang="en-US" sz="1700" dirty="0"/>
           </a:p>
@@ -8479,6 +8599,18 @@
   <p:clrMapOvr>
     <a:masterClrMapping/>
   </p:clrMapOvr>
+  <mc:AlternateContent xmlns:mc="http://schemas.openxmlformats.org/markup-compatibility/2006" xmlns:p14="http://schemas.microsoft.com/office/powerpoint/2010/main">
+    <mc:Choice Requires="p14">
+      <p:transition spd="med" p14:dur="700">
+        <p:fade/>
+      </p:transition>
+    </mc:Choice>
+    <mc:Fallback xmlns="">
+      <p:transition spd="med">
+        <p:fade/>
+      </p:transition>
+    </mc:Fallback>
+  </mc:AlternateContent>
 </p:sld>
 </file>
 
@@ -8969,7 +9101,7 @@
         </p:nvSpPr>
         <p:spPr>
           <a:xfrm>
-            <a:off x="420624" y="3438144"/>
+            <a:off x="420624" y="3463544"/>
             <a:ext cx="1353312" cy="109728"/>
           </a:xfrm>
           <a:prstGeom prst="rect">
@@ -9001,7 +9133,7 @@
         </p:nvSpPr>
         <p:spPr>
           <a:xfrm>
-            <a:off x="420624" y="3438144"/>
+            <a:off x="420624" y="3463544"/>
             <a:ext cx="135331" cy="109728"/>
           </a:xfrm>
           <a:prstGeom prst="rect">
@@ -9565,7 +9697,7 @@
         </p:nvSpPr>
         <p:spPr>
           <a:xfrm>
-            <a:off x="2157984" y="3438144"/>
+            <a:off x="2157984" y="3463544"/>
             <a:ext cx="1353312" cy="109728"/>
           </a:xfrm>
           <a:prstGeom prst="rect">
@@ -9597,7 +9729,7 @@
         </p:nvSpPr>
         <p:spPr>
           <a:xfrm>
-            <a:off x="2157984" y="3438144"/>
+            <a:off x="2157984" y="3463544"/>
             <a:ext cx="270662" cy="109728"/>
           </a:xfrm>
           <a:prstGeom prst="rect">
@@ -10161,7 +10293,7 @@
         </p:nvSpPr>
         <p:spPr>
           <a:xfrm>
-            <a:off x="3895344" y="3438144"/>
+            <a:off x="3895344" y="3463544"/>
             <a:ext cx="1353312" cy="109728"/>
           </a:xfrm>
           <a:prstGeom prst="rect">
@@ -10193,7 +10325,7 @@
         </p:nvSpPr>
         <p:spPr>
           <a:xfrm>
-            <a:off x="3895344" y="3438144"/>
+            <a:off x="3895344" y="3463544"/>
             <a:ext cx="676656" cy="109728"/>
           </a:xfrm>
           <a:prstGeom prst="rect">
@@ -10757,7 +10889,7 @@
         </p:nvSpPr>
         <p:spPr>
           <a:xfrm>
-            <a:off x="5632704" y="3438144"/>
+            <a:off x="5632704" y="3463544"/>
             <a:ext cx="1353312" cy="109728"/>
           </a:xfrm>
           <a:prstGeom prst="rect">
@@ -10789,7 +10921,7 @@
         </p:nvSpPr>
         <p:spPr>
           <a:xfrm>
-            <a:off x="5632704" y="3438144"/>
+            <a:off x="5632704" y="3463544"/>
             <a:ext cx="1014984" cy="109728"/>
           </a:xfrm>
           <a:prstGeom prst="rect">
@@ -11353,7 +11485,7 @@
         </p:nvSpPr>
         <p:spPr>
           <a:xfrm>
-            <a:off x="7370064" y="3438144"/>
+            <a:off x="7370064" y="3463544"/>
             <a:ext cx="1353312" cy="109728"/>
           </a:xfrm>
           <a:prstGeom prst="rect">
@@ -11385,7 +11517,7 @@
         </p:nvSpPr>
         <p:spPr>
           <a:xfrm>
-            <a:off x="7370064" y="3438144"/>
+            <a:off x="7370064" y="3463544"/>
             <a:ext cx="1217981" cy="109728"/>
           </a:xfrm>
           <a:prstGeom prst="rect">
@@ -11644,7 +11776,7 @@
         </p:nvSpPr>
         <p:spPr>
           <a:xfrm>
-            <a:off x="2926080" y="1024128"/>
+            <a:off x="2926080" y="900684"/>
             <a:ext cx="1554480" cy="347472"/>
           </a:xfrm>
           <a:prstGeom prst="rect">
@@ -11683,7 +11815,7 @@
         </p:nvSpPr>
         <p:spPr>
           <a:xfrm>
-            <a:off x="2926080" y="1024128"/>
+            <a:off x="2971800" y="905256"/>
             <a:ext cx="1554480" cy="347472"/>
           </a:xfrm>
           <a:prstGeom prst="rect">
@@ -11900,6 +12032,18 @@
   <p:clrMapOvr>
     <a:masterClrMapping/>
   </p:clrMapOvr>
+  <mc:AlternateContent xmlns:mc="http://schemas.openxmlformats.org/markup-compatibility/2006" xmlns:p14="http://schemas.microsoft.com/office/powerpoint/2010/main">
+    <mc:Choice Requires="p14">
+      <p:transition spd="med" p14:dur="700">
+        <p:fade/>
+      </p:transition>
+    </mc:Choice>
+    <mc:Fallback xmlns="">
+      <p:transition spd="med">
+        <p:fade/>
+      </p:transition>
+    </mc:Fallback>
+  </mc:AlternateContent>
 </p:sld>
 </file>
 
@@ -12941,6 +13085,18 @@
   <p:clrMapOvr>
     <a:masterClrMapping/>
   </p:clrMapOvr>
+  <mc:AlternateContent xmlns:mc="http://schemas.openxmlformats.org/markup-compatibility/2006" xmlns:p14="http://schemas.microsoft.com/office/powerpoint/2010/main">
+    <mc:Choice Requires="p14">
+      <p:transition spd="med" p14:dur="700">
+        <p:fade/>
+      </p:transition>
+    </mc:Choice>
+    <mc:Fallback xmlns="">
+      <p:transition spd="med">
+        <p:fade/>
+      </p:transition>
+    </mc:Fallback>
+  </mc:AlternateContent>
 </p:sld>
 </file>
 
@@ -13194,6 +13350,18 @@
   <p:clrMapOvr>
     <a:masterClrMapping/>
   </p:clrMapOvr>
+  <mc:AlternateContent xmlns:mc="http://schemas.openxmlformats.org/markup-compatibility/2006" xmlns:p14="http://schemas.microsoft.com/office/powerpoint/2010/main">
+    <mc:Choice Requires="p14">
+      <p:transition spd="med" p14:dur="700">
+        <p:fade/>
+      </p:transition>
+    </mc:Choice>
+    <mc:Fallback xmlns="">
+      <p:transition spd="med">
+        <p:fade/>
+      </p:transition>
+    </mc:Fallback>
+  </mc:AlternateContent>
 </p:sld>
 </file>
 
@@ -14400,6 +14568,18 @@
   <p:clrMapOvr>
     <a:masterClrMapping/>
   </p:clrMapOvr>
+  <mc:AlternateContent xmlns:mc="http://schemas.openxmlformats.org/markup-compatibility/2006" xmlns:p14="http://schemas.microsoft.com/office/powerpoint/2010/main">
+    <mc:Choice Requires="p14">
+      <p:transition spd="med" p14:dur="700">
+        <p:fade/>
+      </p:transition>
+    </mc:Choice>
+    <mc:Fallback xmlns="">
+      <p:transition spd="med">
+        <p:fade/>
+      </p:transition>
+    </mc:Fallback>
+  </mc:AlternateContent>
 </p:sld>
 </file>
 
@@ -15627,6 +15807,18 @@
   <p:clrMapOvr>
     <a:masterClrMapping/>
   </p:clrMapOvr>
+  <mc:AlternateContent xmlns:mc="http://schemas.openxmlformats.org/markup-compatibility/2006" xmlns:p14="http://schemas.microsoft.com/office/powerpoint/2010/main">
+    <mc:Choice Requires="p14">
+      <p:transition spd="med" p14:dur="700">
+        <p:fade/>
+      </p:transition>
+    </mc:Choice>
+    <mc:Fallback xmlns="">
+      <p:transition spd="med">
+        <p:fade/>
+      </p:transition>
+    </mc:Fallback>
+  </mc:AlternateContent>
 </p:sld>
 </file>
 
@@ -18388,6 +18580,18 @@
   <p:clrMapOvr>
     <a:masterClrMapping/>
   </p:clrMapOvr>
+  <mc:AlternateContent xmlns:mc="http://schemas.openxmlformats.org/markup-compatibility/2006" xmlns:p14="http://schemas.microsoft.com/office/powerpoint/2010/main">
+    <mc:Choice Requires="p14">
+      <p:transition spd="med" p14:dur="700">
+        <p:fade/>
+      </p:transition>
+    </mc:Choice>
+    <mc:Fallback xmlns="">
+      <p:transition spd="med">
+        <p:fade/>
+      </p:transition>
+    </mc:Fallback>
+  </mc:AlternateContent>
 </p:sld>
 </file>
 
@@ -19504,6 +19708,18 @@
   <p:clrMapOvr>
     <a:masterClrMapping/>
   </p:clrMapOvr>
+  <mc:AlternateContent xmlns:mc="http://schemas.openxmlformats.org/markup-compatibility/2006" xmlns:p14="http://schemas.microsoft.com/office/powerpoint/2010/main">
+    <mc:Choice Requires="p14">
+      <p:transition spd="med" p14:dur="700">
+        <p:fade/>
+      </p:transition>
+    </mc:Choice>
+    <mc:Fallback xmlns="">
+      <p:transition spd="med">
+        <p:fade/>
+      </p:transition>
+    </mc:Fallback>
+  </mc:AlternateContent>
 </p:sld>
 </file>
 

</xml_diff>